<commit_message>
minor correction in representing negative numbers slide
</commit_message>
<xml_diff>
--- a/Lec-2.pptx
+++ b/Lec-2.pptx
@@ -304,7 +304,7 @@
               <a:pPr>
                 <a:defRPr/>
               </a:pPr>
-              <a:t>8/4/2026</a:t>
+              <a:t>8/11/2026</a:t>
             </a:fld>
             <a:endParaRPr lang="en-US"/>
           </a:p>
@@ -8914,10 +8914,16 @@
               <a:buChar char="-"/>
             </a:pPr>
             <a:r>
+              <a:rPr lang="en-US" sz="2200">
+                <a:latin typeface="+mj-lt"/>
+              </a:rPr>
+              <a:t>The complement </a:t>
+            </a:r>
+            <a:r>
               <a:rPr lang="en-US" sz="2200" dirty="0">
                 <a:latin typeface="+mj-lt"/>
               </a:rPr>
-              <a:t>The signed complement system: negative number is stored as its complement, with left-most bit indicating the sign</a:t>
+              <a:t>system: negative number is stored as its complement, with left-most bit indicating the sign</a:t>
             </a:r>
           </a:p>
           <a:p>
@@ -8974,7 +8980,7 @@
               <a:rPr lang="en-US" sz="2200" b="1" dirty="0">
                 <a:latin typeface="+mj-lt"/>
               </a:rPr>
-              <a:t>It makes addition and subtraction easy (see tutorial 1)!</a:t>
+              <a:t>It makes addition and subtraction easy for computers (see tutorial 1)!</a:t>
             </a:r>
           </a:p>
         </p:txBody>

</xml_diff>